<commit_message>
Every deck now has a unique background architecture: add 13 more layouts (footer, rrail, frame, numtab, sidebarL, hangrule, bodycard, doublebar, bracketL, topline, lwash, tintstripe, splitcol); reassign all 13 non-deployed decks so all 25 use a distinct content architecture (no template reuses a deployed deck's structure)
</commit_message>
<xml_diff>
--- a/ppt/X25171216_smart-agriculture.pptx
+++ b/ppt/X25171216_smart-agriculture.pptx
@@ -3348,8 +3348,8 @@
         </p:nvSpPr>
         <p:spPr>
           <a:xfrm>
-            <a:off x="0" y="0"/>
-            <a:ext cx="4114800" cy="6858000"/>
+            <a:off x="-91440" y="6419088"/>
+            <a:ext cx="12435840" cy="548640"/>
           </a:xfrm>
           <a:prstGeom prst="rect">
             <a:avLst/>
@@ -3396,8 +3396,8 @@
         </p:nvSpPr>
         <p:spPr>
           <a:xfrm>
-            <a:off x="457200" y="640080"/>
-            <a:ext cx="3291840" cy="4572000"/>
+            <a:off x="640080" y="384048"/>
+            <a:ext cx="10972800" cy="868680"/>
           </a:xfrm>
         </p:spPr>
         <p:txBody>
@@ -3406,9 +3406,9 @@
           <a:p>
             <a:pPr algn="l"/>
             <a:r>
-              <a:rPr b="1" sz="2200">
-                <a:solidFill>
-                  <a:srgbClr val="FFFFFF"/>
+              <a:rPr b="1" sz="2700">
+                <a:solidFill>
+                  <a:srgbClr val="3A7D34"/>
                 </a:solidFill>
                 <a:latin typeface="Trebuchet MS"/>
               </a:rPr>
@@ -3429,8 +3429,8 @@
         </p:nvSpPr>
         <p:spPr>
           <a:xfrm>
-            <a:off x="4572000" y="640080"/>
-            <a:ext cx="6492240" cy="5577840"/>
+            <a:off x="658368" y="1481328"/>
+            <a:ext cx="10972800" cy="4617720"/>
           </a:xfrm>
         </p:spPr>
         <p:txBody>
@@ -3554,67 +3554,14 @@
       </p:sp>
       <p:sp>
         <p:nvSpPr>
-          <p:cNvPr id="5" name="TextBox 4"/>
-          <p:cNvSpPr txBox="1"/>
+          <p:cNvPr id="5" name="Rectangle 4"/>
+          <p:cNvSpPr/>
           <p:nvPr/>
         </p:nvSpPr>
         <p:spPr>
           <a:xfrm>
-            <a:off x="502920" y="6126480"/>
-            <a:ext cx="1097280" cy="457200"/>
-          </a:xfrm>
-          <a:prstGeom prst="rect">
-            <a:avLst/>
-          </a:prstGeom>
-          <a:noFill/>
-        </p:spPr>
-        <p:txBody>
-          <a:bodyPr wrap="square" anchor="t">
-            <a:spAutoFit/>
-          </a:bodyPr>
-          <a:lstStyle/>
-          <a:p>
-            <a:pPr algn="l"/>
-            <a:r>
-              <a:rPr sz="1400" b="1" i="0">
-                <a:solidFill>
-                  <a:srgbClr val="FFFFFF"/>
-                </a:solidFill>
-                <a:latin typeface="Trebuchet MS"/>
-              </a:rPr>
-              <a:t>01</a:t>
-            </a:r>
-          </a:p>
-        </p:txBody>
-      </p:sp>
-    </p:spTree>
-  </p:cSld>
-  <p:clrMapOvr>
-    <a:masterClrMapping/>
-  </p:clrMapOvr>
-</p:sld>
-</file>
-
-<file path=ppt/slides/slide3.xml><?xml version="1.0" encoding="utf-8"?>
-<p:sld xmlns:a="http://schemas.openxmlformats.org/drawingml/2006/main" xmlns:p="http://schemas.openxmlformats.org/presentationml/2006/main" xmlns:r="http://schemas.openxmlformats.org/officeDocument/2006/relationships">
-  <p:cSld>
-    <p:spTree>
-      <p:nvGrpSpPr>
-        <p:cNvPr id="1" name=""/>
-        <p:cNvGrpSpPr/>
-        <p:nvPr/>
-      </p:nvGrpSpPr>
-      <p:grpSpPr/>
-      <p:sp>
-        <p:nvSpPr>
-          <p:cNvPr id="4" name="Rectangle 3"/>
-          <p:cNvSpPr/>
-          <p:nvPr/>
-        </p:nvSpPr>
-        <p:spPr>
-          <a:xfrm>
-            <a:off x="0" y="0"/>
-            <a:ext cx="4114800" cy="6858000"/>
+            <a:off x="658368" y="1261872"/>
+            <a:ext cx="3108960" cy="36576"/>
           </a:xfrm>
           <a:prstGeom prst="rect">
             <a:avLst/>
@@ -3649,217 +3596,6 @@
           </a:p>
         </p:txBody>
       </p:sp>
-      <p:sp>
-        <p:nvSpPr>
-          <p:cNvPr id="2" name="Title 1"/>
-          <p:cNvSpPr>
-            <a:spLocks noGrp="1"/>
-          </p:cNvSpPr>
-          <p:nvPr>
-            <p:ph type="title"/>
-          </p:nvPr>
-        </p:nvSpPr>
-        <p:spPr>
-          <a:xfrm>
-            <a:off x="457200" y="640080"/>
-            <a:ext cx="3291840" cy="4572000"/>
-          </a:xfrm>
-        </p:spPr>
-        <p:txBody>
-          <a:bodyPr wrap="square" anchor="t"/>
-          <a:lstStyle/>
-          <a:p>
-            <a:pPr algn="l"/>
-            <a:r>
-              <a:rPr b="1" sz="2200">
-                <a:solidFill>
-                  <a:srgbClr val="FFFFFF"/>
-                </a:solidFill>
-                <a:latin typeface="Trebuchet MS"/>
-              </a:rPr>
-              <a:t>How It Works: Edge to Cloud</a:t>
-            </a:r>
-          </a:p>
-        </p:txBody>
-      </p:sp>
-      <p:sp>
-        <p:nvSpPr>
-          <p:cNvPr id="3" name="Content Placeholder 2"/>
-          <p:cNvSpPr>
-            <a:spLocks noGrp="1"/>
-          </p:cNvSpPr>
-          <p:nvPr>
-            <p:ph idx="1"/>
-          </p:nvPr>
-        </p:nvSpPr>
-        <p:spPr>
-          <a:xfrm>
-            <a:off x="4526280" y="685800"/>
-            <a:ext cx="3977639" cy="5394960"/>
-          </a:xfrm>
-        </p:spPr>
-        <p:txBody>
-          <a:bodyPr wrap="square">
-            <a:normAutofit/>
-          </a:bodyPr>
-          <a:lstStyle/>
-          <a:p>
-            <a:pPr>
-              <a:spcAft>
-                <a:spcPts val="800"/>
-              </a:spcAft>
-            </a:pPr>
-            <a:r>
-              <a:rPr sz="1500" b="0">
-                <a:solidFill>
-                  <a:srgbClr val="232A26"/>
-                </a:solidFill>
-                <a:latin typeface="Verdana"/>
-              </a:rPr>
-              <a:t>Field sensors: five sensor types (soil moisture, temperature, humidity, light, rainfall) sample every 2 to 4 seconds.</a:t>
-            </a:r>
-          </a:p>
-          <a:p>
-            <a:pPr>
-              <a:spcAft>
-                <a:spcPts val="800"/>
-              </a:spcAft>
-            </a:pPr>
-            <a:r>
-              <a:rPr sz="1500" b="0">
-                <a:solidFill>
-                  <a:srgbClr val="232A26"/>
-                </a:solidFill>
-                <a:latin typeface="Verdana"/>
-              </a:rPr>
-              <a:t>Fog node: windows each stream over 10 seconds, aggregates min, max, and average, and raises alerts locally.</a:t>
-            </a:r>
-          </a:p>
-          <a:p>
-            <a:pPr>
-              <a:spcAft>
-                <a:spcPts val="800"/>
-              </a:spcAft>
-            </a:pPr>
-            <a:r>
-              <a:rPr sz="1500" b="0">
-                <a:solidFill>
-                  <a:srgbClr val="232A26"/>
-                </a:solidFill>
-                <a:latin typeface="Verdana"/>
-              </a:rPr>
-              <a:t>Amazon SQS then AWS Lambda: a managed queue absorbs batched window summaries and levels the load, then a serverless function fires on each summary and ingests it with no servers to manage.</a:t>
-            </a:r>
-          </a:p>
-          <a:p>
-            <a:pPr>
-              <a:spcAft>
-                <a:spcPts val="800"/>
-              </a:spcAft>
-            </a:pPr>
-            <a:r>
-              <a:rPr sz="1500" b="0">
-                <a:solidFill>
-                  <a:srgbClr val="232A26"/>
-                </a:solidFill>
-                <a:latin typeface="Verdana"/>
-              </a:rPr>
-              <a:t>Amazon DynamoDB: every window lands as one record, keyed by sensor type and time, ready for fast lookups.</a:t>
-            </a:r>
-          </a:p>
-          <a:p>
-            <a:pPr>
-              <a:spcAft>
-                <a:spcPts val="800"/>
-              </a:spcAft>
-            </a:pPr>
-            <a:r>
-              <a:rPr sz="1500" b="0">
-                <a:solidFill>
-                  <a:srgbClr val="232A26"/>
-                </a:solidFill>
-                <a:latin typeface="Verdana"/>
-              </a:rPr>
-              <a:t>Live dashboard: Amazon API Gateway serves the data API and Amazon S3 hosts the page the browser loads.</a:t>
-            </a:r>
-          </a:p>
-          <a:p>
-            <a:pPr>
-              <a:spcAft>
-                <a:spcPts val="800"/>
-              </a:spcAft>
-            </a:pPr>
-            <a:r>
-              <a:rPr sz="1500" b="1">
-                <a:solidFill>
-                  <a:srgbClr val="3A7D34"/>
-                </a:solidFill>
-                <a:latin typeface="Verdana"/>
-              </a:rPr>
-              <a:t>Raw readings never leave the edge; only compact ten-second window summaries cross into the cloud.</a:t>
-            </a:r>
-          </a:p>
-        </p:txBody>
-      </p:sp>
-      <p:sp>
-        <p:nvSpPr>
-          <p:cNvPr id="5" name="TextBox 4"/>
-          <p:cNvSpPr txBox="1"/>
-          <p:nvPr/>
-        </p:nvSpPr>
-        <p:spPr>
-          <a:xfrm>
-            <a:off x="502920" y="6126480"/>
-            <a:ext cx="1097280" cy="457200"/>
-          </a:xfrm>
-          <a:prstGeom prst="rect">
-            <a:avLst/>
-          </a:prstGeom>
-          <a:noFill/>
-        </p:spPr>
-        <p:txBody>
-          <a:bodyPr wrap="square" anchor="t">
-            <a:spAutoFit/>
-          </a:bodyPr>
-          <a:lstStyle/>
-          <a:p>
-            <a:pPr algn="l"/>
-            <a:r>
-              <a:rPr sz="1400" b="1" i="0">
-                <a:solidFill>
-                  <a:srgbClr val="FFFFFF"/>
-                </a:solidFill>
-                <a:latin typeface="Trebuchet MS"/>
-              </a:rPr>
-              <a:t>02</a:t>
-            </a:r>
-          </a:p>
-        </p:txBody>
-      </p:sp>
-      <p:pic>
-        <p:nvPicPr>
-          <p:cNvPr id="6" name="Picture 5" descr="topology.png"/>
-          <p:cNvPicPr>
-            <a:picLocks noChangeAspect="1"/>
-          </p:cNvPicPr>
-          <p:nvPr/>
-        </p:nvPicPr>
-        <p:blipFill>
-          <a:blip r:embed="rId2"/>
-          <a:stretch>
-            <a:fillRect/>
-          </a:stretch>
-        </p:blipFill>
-        <p:spPr>
-          <a:xfrm>
-            <a:off x="8686800" y="2594232"/>
-            <a:ext cx="3063239" cy="1303775"/>
-          </a:xfrm>
-          <a:prstGeom prst="rect">
-            <a:avLst/>
-          </a:prstGeom>
-        </p:spPr>
-      </p:pic>
     </p:spTree>
   </p:cSld>
   <p:clrMapOvr>
@@ -3868,7 +3604,7 @@
 </p:sld>
 </file>
 
-<file path=ppt/slides/slide4.xml><?xml version="1.0" encoding="utf-8"?>
+<file path=ppt/slides/slide3.xml><?xml version="1.0" encoding="utf-8"?>
 <p:sld xmlns:a="http://schemas.openxmlformats.org/drawingml/2006/main" xmlns:p="http://schemas.openxmlformats.org/presentationml/2006/main" xmlns:r="http://schemas.openxmlformats.org/officeDocument/2006/relationships">
   <p:cSld>
     <p:spTree>
@@ -3886,8 +3622,8 @@
         </p:nvSpPr>
         <p:spPr>
           <a:xfrm>
-            <a:off x="0" y="0"/>
-            <a:ext cx="4114800" cy="6858000"/>
+            <a:off x="-91440" y="6419088"/>
+            <a:ext cx="12435840" cy="548640"/>
           </a:xfrm>
           <a:prstGeom prst="rect">
             <a:avLst/>
@@ -3934,8 +3670,8 @@
         </p:nvSpPr>
         <p:spPr>
           <a:xfrm>
-            <a:off x="457200" y="640080"/>
-            <a:ext cx="3291840" cy="4572000"/>
+            <a:off x="640080" y="384048"/>
+            <a:ext cx="10972800" cy="868680"/>
           </a:xfrm>
         </p:spPr>
         <p:txBody>
@@ -3944,13 +3680,13 @@
           <a:p>
             <a:pPr algn="l"/>
             <a:r>
-              <a:rPr b="1" sz="2200">
-                <a:solidFill>
-                  <a:srgbClr val="FFFFFF"/>
+              <a:rPr b="1" sz="2700">
+                <a:solidFill>
+                  <a:srgbClr val="3A7D34"/>
                 </a:solidFill>
                 <a:latin typeface="Trebuchet MS"/>
               </a:rPr>
-              <a:t>Live Demonstration Highlights</a:t>
+              <a:t>How It Works: Edge to Cloud</a:t>
             </a:r>
           </a:p>
         </p:txBody>
@@ -3967,8 +3703,8 @@
         </p:nvSpPr>
         <p:spPr>
           <a:xfrm>
-            <a:off x="4526280" y="685800"/>
-            <a:ext cx="3977639" cy="5394960"/>
+            <a:off x="658368" y="1481328"/>
+            <a:ext cx="5760720" cy="4480560"/>
           </a:xfrm>
         </p:spPr>
         <p:txBody>
@@ -3989,7 +3725,7 @@
                 </a:solidFill>
                 <a:latin typeface="Verdana"/>
               </a:rPr>
-              <a:t>The S3-hosted dashboard during live verification shows per-sensor panels, trend charts, and an active alert banner.</a:t>
+              <a:t>Field sensors: five sensor types (soil moisture, temperature, humidity, light, rainfall) sample every 2 to 4 seconds.</a:t>
             </a:r>
           </a:p>
           <a:p>
@@ -4005,7 +3741,7 @@
                 </a:solidFill>
                 <a:latin typeface="Verdana"/>
               </a:rPr>
-              <a:t>Every pipeline health check green: fog node, queue, Lambda, and end-to-end freshness all report healthy on the live API, with the freshest reading just 1.88 seconds old.</a:t>
+              <a:t>Fog node: windows each stream over 10 seconds, aggregates min, max, and average, and raises alerts locally.</a:t>
             </a:r>
           </a:p>
           <a:p>
@@ -4021,7 +3757,7 @@
                 </a:solidFill>
                 <a:latin typeface="Verdana"/>
               </a:rPr>
-              <a:t>39 automated tests pass, covering the sensors' bounded random walk, fog aggregation and alert rules, SQS batching, and every dashboard route.</a:t>
+              <a:t>Amazon SQS then AWS Lambda: a managed queue absorbs batched window summaries and levels the load, then a serverless function fires on each summary and ingests it with no servers to manage.</a:t>
             </a:r>
           </a:p>
           <a:p>
@@ -4037,98 +3773,53 @@
                 </a:solidFill>
                 <a:latin typeface="Verdana"/>
               </a:rPr>
-              <a:t>300-message burst absorbed: fired at the live queue in 4.5 seconds, about 67 per second, with every message processed and stored, verified directly in DynamoDB.</a:t>
-            </a:r>
-          </a:p>
-        </p:txBody>
-      </p:sp>
-      <p:sp>
-        <p:nvSpPr>
-          <p:cNvPr id="5" name="TextBox 4"/>
-          <p:cNvSpPr txBox="1"/>
+              <a:t>Amazon DynamoDB: every window lands as one record, keyed by sensor type and time, ready for fast lookups.</a:t>
+            </a:r>
+          </a:p>
+          <a:p>
+            <a:pPr>
+              <a:spcAft>
+                <a:spcPts val="800"/>
+              </a:spcAft>
+            </a:pPr>
+            <a:r>
+              <a:rPr sz="1500" b="0">
+                <a:solidFill>
+                  <a:srgbClr val="232A26"/>
+                </a:solidFill>
+                <a:latin typeface="Verdana"/>
+              </a:rPr>
+              <a:t>Live dashboard: Amazon API Gateway serves the data API and Amazon S3 hosts the page the browser loads.</a:t>
+            </a:r>
+          </a:p>
+          <a:p>
+            <a:pPr>
+              <a:spcAft>
+                <a:spcPts val="800"/>
+              </a:spcAft>
+            </a:pPr>
+            <a:r>
+              <a:rPr sz="1500" b="1">
+                <a:solidFill>
+                  <a:srgbClr val="3A7D34"/>
+                </a:solidFill>
+                <a:latin typeface="Verdana"/>
+              </a:rPr>
+              <a:t>Raw readings never leave the edge; only compact ten-second window summaries cross into the cloud.</a:t>
+            </a:r>
+          </a:p>
+        </p:txBody>
+      </p:sp>
+      <p:sp>
+        <p:nvSpPr>
+          <p:cNvPr id="5" name="Rectangle 4"/>
+          <p:cNvSpPr/>
           <p:nvPr/>
         </p:nvSpPr>
         <p:spPr>
           <a:xfrm>
-            <a:off x="502920" y="6126480"/>
-            <a:ext cx="1097280" cy="457200"/>
-          </a:xfrm>
-          <a:prstGeom prst="rect">
-            <a:avLst/>
-          </a:prstGeom>
-          <a:noFill/>
-        </p:spPr>
-        <p:txBody>
-          <a:bodyPr wrap="square" anchor="t">
-            <a:spAutoFit/>
-          </a:bodyPr>
-          <a:lstStyle/>
-          <a:p>
-            <a:pPr algn="l"/>
-            <a:r>
-              <a:rPr sz="1400" b="1" i="0">
-                <a:solidFill>
-                  <a:srgbClr val="FFFFFF"/>
-                </a:solidFill>
-                <a:latin typeface="Trebuchet MS"/>
-              </a:rPr>
-              <a:t>03</a:t>
-            </a:r>
-          </a:p>
-        </p:txBody>
-      </p:sp>
-      <p:pic>
-        <p:nvPicPr>
-          <p:cNvPr id="6" name="Picture 5" descr="dashboard.png"/>
-          <p:cNvPicPr>
-            <a:picLocks noChangeAspect="1"/>
-          </p:cNvPicPr>
-          <p:nvPr/>
-        </p:nvPicPr>
-        <p:blipFill>
-          <a:blip r:embed="rId2"/>
-          <a:stretch>
-            <a:fillRect/>
-          </a:stretch>
-        </p:blipFill>
-        <p:spPr>
-          <a:xfrm>
-            <a:off x="8686800" y="1810226"/>
-            <a:ext cx="3063239" cy="2871787"/>
-          </a:xfrm>
-          <a:prstGeom prst="rect">
-            <a:avLst/>
-          </a:prstGeom>
-        </p:spPr>
-      </p:pic>
-    </p:spTree>
-  </p:cSld>
-  <p:clrMapOvr>
-    <a:masterClrMapping/>
-  </p:clrMapOvr>
-</p:sld>
-</file>
-
-<file path=ppt/slides/slide5.xml><?xml version="1.0" encoding="utf-8"?>
-<p:sld xmlns:a="http://schemas.openxmlformats.org/drawingml/2006/main" xmlns:p="http://schemas.openxmlformats.org/presentationml/2006/main" xmlns:r="http://schemas.openxmlformats.org/officeDocument/2006/relationships">
-  <p:cSld>
-    <p:spTree>
-      <p:nvGrpSpPr>
-        <p:cNvPr id="1" name=""/>
-        <p:cNvGrpSpPr/>
-        <p:nvPr/>
-      </p:nvGrpSpPr>
-      <p:grpSpPr/>
-      <p:sp>
-        <p:nvSpPr>
-          <p:cNvPr id="4" name="Rectangle 3"/>
-          <p:cNvSpPr/>
-          <p:nvPr/>
-        </p:nvSpPr>
-        <p:spPr>
-          <a:xfrm>
-            <a:off x="0" y="0"/>
-            <a:ext cx="4114800" cy="6858000"/>
+            <a:off x="658368" y="1261872"/>
+            <a:ext cx="3108960" cy="36576"/>
           </a:xfrm>
           <a:prstGeom prst="rect">
             <a:avLst/>
@@ -4163,193 +3854,30 @@
           </a:p>
         </p:txBody>
       </p:sp>
-      <p:sp>
-        <p:nvSpPr>
-          <p:cNvPr id="2" name="Title 1"/>
-          <p:cNvSpPr>
-            <a:spLocks noGrp="1"/>
-          </p:cNvSpPr>
-          <p:nvPr>
-            <p:ph type="title"/>
-          </p:nvPr>
-        </p:nvSpPr>
+      <p:pic>
+        <p:nvPicPr>
+          <p:cNvPr id="6" name="Picture 5" descr="topology.png"/>
+          <p:cNvPicPr>
+            <a:picLocks noChangeAspect="1"/>
+          </p:cNvPicPr>
+          <p:nvPr/>
+        </p:nvPicPr>
+        <p:blipFill>
+          <a:blip r:embed="rId2"/>
+          <a:stretch>
+            <a:fillRect/>
+          </a:stretch>
+        </p:blipFill>
         <p:spPr>
           <a:xfrm>
-            <a:off x="457200" y="640080"/>
-            <a:ext cx="3291840" cy="4572000"/>
-          </a:xfrm>
-        </p:spPr>
-        <p:txBody>
-          <a:bodyPr wrap="square" anchor="t"/>
-          <a:lstStyle/>
-          <a:p>
-            <a:pPr algn="l"/>
-            <a:r>
-              <a:rPr b="1" sz="1800">
-                <a:solidFill>
-                  <a:srgbClr val="FFFFFF"/>
-                </a:solidFill>
-                <a:latin typeface="Trebuchet MS"/>
-              </a:rPr>
-              <a:t>The Hardest Part: A Defect the Emulator Hid</a:t>
-            </a:r>
-          </a:p>
-        </p:txBody>
-      </p:sp>
-      <p:sp>
-        <p:nvSpPr>
-          <p:cNvPr id="3" name="Content Placeholder 2"/>
-          <p:cNvSpPr>
-            <a:spLocks noGrp="1"/>
-          </p:cNvSpPr>
-          <p:nvPr>
-            <p:ph idx="1"/>
-          </p:nvPr>
-        </p:nvSpPr>
-        <p:spPr>
-          <a:xfrm>
-            <a:off x="4572000" y="640080"/>
-            <a:ext cx="6492240" cy="5577840"/>
-          </a:xfrm>
-        </p:spPr>
-        <p:txBody>
-          <a:bodyPr wrap="square">
-            <a:normAutofit/>
-          </a:bodyPr>
-          <a:lstStyle/>
-          <a:p>
-            <a:pPr>
-              <a:spcAft>
-                <a:spcPts val="900"/>
-              </a:spcAft>
-            </a:pPr>
-            <a:r>
-              <a:rPr sz="1700" b="1">
-                <a:solidFill>
-                  <a:srgbClr val="3A7D34"/>
-                </a:solidFill>
-                <a:latin typeface="Verdana"/>
-              </a:rPr>
-              <a:t>The problem: a record count that quietly lied</a:t>
-            </a:r>
-          </a:p>
-          <a:p>
-            <a:pPr lvl="1">
-              <a:spcAft>
-                <a:spcPts val="900"/>
-              </a:spcAft>
-            </a:pPr>
-            <a:r>
-              <a:rPr sz="1500" b="0">
-                <a:solidFill>
-                  <a:srgbClr val="232A26"/>
-                </a:solidFill>
-                <a:latin typeface="Verdana"/>
-              </a:rPr>
-              <a:t>The dashboard totalled its stored records with a single DynamoDB scan. DynamoDB caps every scan at about 1 MB, so beyond the first page the count simply stops, with no error, no warning, just a smaller number.</a:t>
-            </a:r>
-          </a:p>
-          <a:p>
-            <a:pPr>
-              <a:spcAft>
-                <a:spcPts val="900"/>
-              </a:spcAft>
-            </a:pPr>
-            <a:r>
-              <a:rPr sz="1700" b="1">
-                <a:solidFill>
-                  <a:srgbClr val="3A7D34"/>
-                </a:solidFill>
-                <a:latin typeface="Verdana"/>
-              </a:rPr>
-              <a:t>Why it was hard: nothing ever failed</a:t>
-            </a:r>
-          </a:p>
-          <a:p>
-            <a:pPr lvl="1">
-              <a:spcAft>
-                <a:spcPts val="900"/>
-              </a:spcAft>
-            </a:pPr>
-            <a:r>
-              <a:rPr sz="1500" b="0">
-                <a:solidFill>
-                  <a:srgbClr val="232A26"/>
-                </a:solidFill>
-                <a:latin typeface="Verdana"/>
-              </a:rPr>
-              <a:t>All 39 tests passed, the full emulator-backed integration run passed, and demo-sized data looked correct. With no failing signal to chase, the defect surfaced only when the pipeline ran on the real AWS account.</a:t>
-            </a:r>
-          </a:p>
-          <a:p>
-            <a:pPr>
-              <a:spcAft>
-                <a:spcPts val="900"/>
-              </a:spcAft>
-            </a:pPr>
-            <a:r>
-              <a:rPr sz="1700" b="1">
-                <a:solidFill>
-                  <a:srgbClr val="3A7D34"/>
-                </a:solidFill>
-                <a:latin typeface="Verdana"/>
-              </a:rPr>
-              <a:t>The fix: follow the pagination cursor</a:t>
-            </a:r>
-          </a:p>
-          <a:p>
-            <a:pPr lvl="1">
-              <a:spcAft>
-                <a:spcPts val="900"/>
-              </a:spcAft>
-            </a:pPr>
-            <a:r>
-              <a:rPr sz="1500" b="0">
-                <a:solidFill>
-                  <a:srgbClr val="232A26"/>
-                </a:solidFill>
-                <a:latin typeface="Verdana"/>
-              </a:rPr>
-              <a:t>The count now walks DynamoDB's pagination cursor and sums every page. It is locked in by a three-page test (500 + 500 + 214 = 1,214) and re-verified against the live deployed table.</a:t>
-            </a:r>
-          </a:p>
-        </p:txBody>
-      </p:sp>
-      <p:sp>
-        <p:nvSpPr>
-          <p:cNvPr id="5" name="TextBox 4"/>
-          <p:cNvSpPr txBox="1"/>
-          <p:nvPr/>
-        </p:nvSpPr>
-        <p:spPr>
-          <a:xfrm>
-            <a:off x="502920" y="6126480"/>
-            <a:ext cx="1097280" cy="457200"/>
+            <a:off x="6629400" y="2599881"/>
+            <a:ext cx="5120640" cy="2179445"/>
           </a:xfrm>
           <a:prstGeom prst="rect">
             <a:avLst/>
           </a:prstGeom>
-          <a:noFill/>
         </p:spPr>
-        <p:txBody>
-          <a:bodyPr wrap="square" anchor="t">
-            <a:spAutoFit/>
-          </a:bodyPr>
-          <a:lstStyle/>
-          <a:p>
-            <a:pPr algn="l"/>
-            <a:r>
-              <a:rPr sz="1400" b="1" i="0">
-                <a:solidFill>
-                  <a:srgbClr val="FFFFFF"/>
-                </a:solidFill>
-                <a:latin typeface="Trebuchet MS"/>
-              </a:rPr>
-              <a:t>04</a:t>
-            </a:r>
-          </a:p>
-        </p:txBody>
-      </p:sp>
+      </p:pic>
     </p:spTree>
   </p:cSld>
   <p:clrMapOvr>
@@ -4358,7 +3886,7 @@
 </p:sld>
 </file>
 
-<file path=ppt/slides/slide6.xml><?xml version="1.0" encoding="utf-8"?>
+<file path=ppt/slides/slide4.xml><?xml version="1.0" encoding="utf-8"?>
 <p:sld xmlns:a="http://schemas.openxmlformats.org/drawingml/2006/main" xmlns:p="http://schemas.openxmlformats.org/presentationml/2006/main" xmlns:r="http://schemas.openxmlformats.org/officeDocument/2006/relationships">
   <p:cSld>
     <p:spTree>
@@ -4376,8 +3904,8 @@
         </p:nvSpPr>
         <p:spPr>
           <a:xfrm>
-            <a:off x="0" y="0"/>
-            <a:ext cx="4114800" cy="6858000"/>
+            <a:off x="-91440" y="6419088"/>
+            <a:ext cx="12435840" cy="548640"/>
           </a:xfrm>
           <a:prstGeom prst="rect">
             <a:avLst/>
@@ -4424,8 +3952,8 @@
         </p:nvSpPr>
         <p:spPr>
           <a:xfrm>
-            <a:off x="457200" y="640080"/>
-            <a:ext cx="3291840" cy="4572000"/>
+            <a:off x="640080" y="384048"/>
+            <a:ext cx="10972800" cy="868680"/>
           </a:xfrm>
         </p:spPr>
         <p:txBody>
@@ -4434,13 +3962,13 @@
           <a:p>
             <a:pPr algn="l"/>
             <a:r>
-              <a:rPr b="1" sz="2200">
-                <a:solidFill>
-                  <a:srgbClr val="FFFFFF"/>
+              <a:rPr b="1" sz="2700">
+                <a:solidFill>
+                  <a:srgbClr val="3A7D34"/>
                 </a:solidFill>
                 <a:latin typeface="Trebuchet MS"/>
               </a:rPr>
-              <a:t>What This Project Proves</a:t>
+              <a:t>Live Demonstration Highlights</a:t>
             </a:r>
           </a:p>
         </p:txBody>
@@ -4457,8 +3985,258 @@
         </p:nvSpPr>
         <p:spPr>
           <a:xfrm>
-            <a:off x="4572000" y="640080"/>
-            <a:ext cx="6492240" cy="5577840"/>
+            <a:off x="658368" y="1481328"/>
+            <a:ext cx="5760720" cy="4480560"/>
+          </a:xfrm>
+        </p:spPr>
+        <p:txBody>
+          <a:bodyPr wrap="square">
+            <a:normAutofit/>
+          </a:bodyPr>
+          <a:lstStyle/>
+          <a:p>
+            <a:pPr>
+              <a:spcAft>
+                <a:spcPts val="800"/>
+              </a:spcAft>
+            </a:pPr>
+            <a:r>
+              <a:rPr sz="1500" b="0">
+                <a:solidFill>
+                  <a:srgbClr val="232A26"/>
+                </a:solidFill>
+                <a:latin typeface="Verdana"/>
+              </a:rPr>
+              <a:t>The S3-hosted dashboard during live verification shows per-sensor panels, trend charts, and an active alert banner.</a:t>
+            </a:r>
+          </a:p>
+          <a:p>
+            <a:pPr>
+              <a:spcAft>
+                <a:spcPts val="800"/>
+              </a:spcAft>
+            </a:pPr>
+            <a:r>
+              <a:rPr sz="1500" b="0">
+                <a:solidFill>
+                  <a:srgbClr val="232A26"/>
+                </a:solidFill>
+                <a:latin typeface="Verdana"/>
+              </a:rPr>
+              <a:t>Every pipeline health check green: fog node, queue, Lambda, and end-to-end freshness all report healthy on the live API, with the freshest reading just 1.88 seconds old.</a:t>
+            </a:r>
+          </a:p>
+          <a:p>
+            <a:pPr>
+              <a:spcAft>
+                <a:spcPts val="800"/>
+              </a:spcAft>
+            </a:pPr>
+            <a:r>
+              <a:rPr sz="1500" b="0">
+                <a:solidFill>
+                  <a:srgbClr val="232A26"/>
+                </a:solidFill>
+                <a:latin typeface="Verdana"/>
+              </a:rPr>
+              <a:t>39 automated tests pass, covering the sensors' bounded random walk, fog aggregation and alert rules, SQS batching, and every dashboard route.</a:t>
+            </a:r>
+          </a:p>
+          <a:p>
+            <a:pPr>
+              <a:spcAft>
+                <a:spcPts val="800"/>
+              </a:spcAft>
+            </a:pPr>
+            <a:r>
+              <a:rPr sz="1500" b="0">
+                <a:solidFill>
+                  <a:srgbClr val="232A26"/>
+                </a:solidFill>
+                <a:latin typeface="Verdana"/>
+              </a:rPr>
+              <a:t>300-message burst absorbed: fired at the live queue in 4.5 seconds, about 67 per second, with every message processed and stored, verified directly in DynamoDB.</a:t>
+            </a:r>
+          </a:p>
+        </p:txBody>
+      </p:sp>
+      <p:sp>
+        <p:nvSpPr>
+          <p:cNvPr id="5" name="Rectangle 4"/>
+          <p:cNvSpPr/>
+          <p:nvPr/>
+        </p:nvSpPr>
+        <p:spPr>
+          <a:xfrm>
+            <a:off x="658368" y="1261872"/>
+            <a:ext cx="3108960" cy="36576"/>
+          </a:xfrm>
+          <a:prstGeom prst="rect">
+            <a:avLst/>
+          </a:prstGeom>
+          <a:solidFill>
+            <a:srgbClr val="3A7D34"/>
+          </a:solidFill>
+          <a:ln>
+            <a:noFill/>
+          </a:ln>
+          <a:effectLst/>
+        </p:spPr>
+        <p:style>
+          <a:lnRef idx="1">
+            <a:schemeClr val="accent1"/>
+          </a:lnRef>
+          <a:fillRef idx="3">
+            <a:schemeClr val="accent1"/>
+          </a:fillRef>
+          <a:effectRef idx="2">
+            <a:schemeClr val="accent1"/>
+          </a:effectRef>
+          <a:fontRef idx="minor">
+            <a:schemeClr val="lt1"/>
+          </a:fontRef>
+        </p:style>
+        <p:txBody>
+          <a:bodyPr rtlCol="0" anchor="ctr"/>
+          <a:lstStyle/>
+          <a:p>
+            <a:pPr algn="ctr"/>
+          </a:p>
+        </p:txBody>
+      </p:sp>
+      <p:pic>
+        <p:nvPicPr>
+          <p:cNvPr id="6" name="Picture 5" descr="dashboard.png"/>
+          <p:cNvPicPr>
+            <a:picLocks noChangeAspect="1"/>
+          </p:cNvPicPr>
+          <p:nvPr/>
+        </p:nvPicPr>
+        <p:blipFill>
+          <a:blip r:embed="rId2"/>
+          <a:stretch>
+            <a:fillRect/>
+          </a:stretch>
+        </p:blipFill>
+        <p:spPr>
+          <a:xfrm>
+            <a:off x="6873240" y="1517904"/>
+            <a:ext cx="4632960" cy="4343400"/>
+          </a:xfrm>
+          <a:prstGeom prst="rect">
+            <a:avLst/>
+          </a:prstGeom>
+        </p:spPr>
+      </p:pic>
+    </p:spTree>
+  </p:cSld>
+  <p:clrMapOvr>
+    <a:masterClrMapping/>
+  </p:clrMapOvr>
+</p:sld>
+</file>
+
+<file path=ppt/slides/slide5.xml><?xml version="1.0" encoding="utf-8"?>
+<p:sld xmlns:a="http://schemas.openxmlformats.org/drawingml/2006/main" xmlns:p="http://schemas.openxmlformats.org/presentationml/2006/main" xmlns:r="http://schemas.openxmlformats.org/officeDocument/2006/relationships">
+  <p:cSld>
+    <p:spTree>
+      <p:nvGrpSpPr>
+        <p:cNvPr id="1" name=""/>
+        <p:cNvGrpSpPr/>
+        <p:nvPr/>
+      </p:nvGrpSpPr>
+      <p:grpSpPr/>
+      <p:sp>
+        <p:nvSpPr>
+          <p:cNvPr id="4" name="Rectangle 3"/>
+          <p:cNvSpPr/>
+          <p:nvPr/>
+        </p:nvSpPr>
+        <p:spPr>
+          <a:xfrm>
+            <a:off x="-91440" y="6419088"/>
+            <a:ext cx="12435840" cy="548640"/>
+          </a:xfrm>
+          <a:prstGeom prst="rect">
+            <a:avLst/>
+          </a:prstGeom>
+          <a:solidFill>
+            <a:srgbClr val="3A7D34"/>
+          </a:solidFill>
+          <a:ln>
+            <a:noFill/>
+          </a:ln>
+          <a:effectLst/>
+        </p:spPr>
+        <p:style>
+          <a:lnRef idx="1">
+            <a:schemeClr val="accent1"/>
+          </a:lnRef>
+          <a:fillRef idx="3">
+            <a:schemeClr val="accent1"/>
+          </a:fillRef>
+          <a:effectRef idx="2">
+            <a:schemeClr val="accent1"/>
+          </a:effectRef>
+          <a:fontRef idx="minor">
+            <a:schemeClr val="lt1"/>
+          </a:fontRef>
+        </p:style>
+        <p:txBody>
+          <a:bodyPr rtlCol="0" anchor="ctr"/>
+          <a:lstStyle/>
+          <a:p>
+            <a:pPr algn="ctr"/>
+          </a:p>
+        </p:txBody>
+      </p:sp>
+      <p:sp>
+        <p:nvSpPr>
+          <p:cNvPr id="2" name="Title 1"/>
+          <p:cNvSpPr>
+            <a:spLocks noGrp="1"/>
+          </p:cNvSpPr>
+          <p:nvPr>
+            <p:ph type="title"/>
+          </p:nvPr>
+        </p:nvSpPr>
+        <p:spPr>
+          <a:xfrm>
+            <a:off x="640080" y="384048"/>
+            <a:ext cx="10972800" cy="868680"/>
+          </a:xfrm>
+        </p:spPr>
+        <p:txBody>
+          <a:bodyPr wrap="square" anchor="t"/>
+          <a:lstStyle/>
+          <a:p>
+            <a:pPr algn="l"/>
+            <a:r>
+              <a:rPr b="1" sz="2400">
+                <a:solidFill>
+                  <a:srgbClr val="3A7D34"/>
+                </a:solidFill>
+                <a:latin typeface="Trebuchet MS"/>
+              </a:rPr>
+              <a:t>The Hardest Part: A Defect the Emulator Hid</a:t>
+            </a:r>
+          </a:p>
+        </p:txBody>
+      </p:sp>
+      <p:sp>
+        <p:nvSpPr>
+          <p:cNvPr id="3" name="Content Placeholder 2"/>
+          <p:cNvSpPr>
+            <a:spLocks noGrp="1"/>
+          </p:cNvSpPr>
+          <p:nvPr>
+            <p:ph idx="1"/>
+          </p:nvPr>
+        </p:nvSpPr>
+        <p:spPr>
+          <a:xfrm>
+            <a:off x="658368" y="1481328"/>
+            <a:ext cx="10972800" cy="4617720"/>
           </a:xfrm>
         </p:spPr>
         <p:txBody>
@@ -4479,7 +4257,7 @@
                 </a:solidFill>
                 <a:latin typeface="Verdana"/>
               </a:rPr>
-              <a:t>Edge-first design pays off</a:t>
+              <a:t>The problem: a record count that quietly lied</a:t>
             </a:r>
           </a:p>
           <a:p>
@@ -4495,7 +4273,7 @@
                 </a:solidFill>
                 <a:latin typeface="Verdana"/>
               </a:rPr>
-              <a:t>Aggregating and alerting at the fog node keeps raw readings local; alerts fire seconds after a threshold breaks.</a:t>
+              <a:t>The dashboard totalled its stored records with a single DynamoDB scan. DynamoDB caps every scan at about 1 MB, so beyond the first page the count simply stops, with no error, no warning, just a smaller number.</a:t>
             </a:r>
           </a:p>
           <a:p>
@@ -4511,7 +4289,7 @@
                 </a:solidFill>
                 <a:latin typeface="Verdana"/>
               </a:rPr>
-              <a:t>Serverless scales without provisioning</a:t>
+              <a:t>Why it was hard: nothing ever failed</a:t>
             </a:r>
           </a:p>
           <a:p>
@@ -4527,7 +4305,7 @@
                 </a:solidFill>
                 <a:latin typeface="Verdana"/>
               </a:rPr>
-              <a:t>SQS, Lambda, and DynamoDB rode out a 67-message-per-second burst with nothing pre-sized or pre-warmed.</a:t>
+              <a:t>All 39 tests passed, the full emulator-backed integration run passed, and demo-sized data looked correct. With no failing signal to chase, the defect surfaced only when the pipeline ran on the real AWS account.</a:t>
             </a:r>
           </a:p>
           <a:p>
@@ -4543,7 +4321,7 @@
                 </a:solidFill>
                 <a:latin typeface="Verdana"/>
               </a:rPr>
-              <a:t>An emulator is not the cloud</a:t>
+              <a:t>The fix: follow the pagination cursor</a:t>
             </a:r>
           </a:p>
           <a:p>
@@ -4559,9 +4337,171 @@
                 </a:solidFill>
                 <a:latin typeface="Verdana"/>
               </a:rPr>
-              <a:t>Two defects passed every local test and only surfaced against the real AWS deployment.</a:t>
-            </a:r>
-          </a:p>
+              <a:t>The count now walks DynamoDB's pagination cursor and sums every page. It is locked in by a three-page test (500 + 500 + 214 = 1,214) and re-verified against the live deployed table.</a:t>
+            </a:r>
+          </a:p>
+        </p:txBody>
+      </p:sp>
+      <p:sp>
+        <p:nvSpPr>
+          <p:cNvPr id="5" name="Rectangle 4"/>
+          <p:cNvSpPr/>
+          <p:nvPr/>
+        </p:nvSpPr>
+        <p:spPr>
+          <a:xfrm>
+            <a:off x="658368" y="1261872"/>
+            <a:ext cx="3108960" cy="36576"/>
+          </a:xfrm>
+          <a:prstGeom prst="rect">
+            <a:avLst/>
+          </a:prstGeom>
+          <a:solidFill>
+            <a:srgbClr val="3A7D34"/>
+          </a:solidFill>
+          <a:ln>
+            <a:noFill/>
+          </a:ln>
+          <a:effectLst/>
+        </p:spPr>
+        <p:style>
+          <a:lnRef idx="1">
+            <a:schemeClr val="accent1"/>
+          </a:lnRef>
+          <a:fillRef idx="3">
+            <a:schemeClr val="accent1"/>
+          </a:fillRef>
+          <a:effectRef idx="2">
+            <a:schemeClr val="accent1"/>
+          </a:effectRef>
+          <a:fontRef idx="minor">
+            <a:schemeClr val="lt1"/>
+          </a:fontRef>
+        </p:style>
+        <p:txBody>
+          <a:bodyPr rtlCol="0" anchor="ctr"/>
+          <a:lstStyle/>
+          <a:p>
+            <a:pPr algn="ctr"/>
+          </a:p>
+        </p:txBody>
+      </p:sp>
+    </p:spTree>
+  </p:cSld>
+  <p:clrMapOvr>
+    <a:masterClrMapping/>
+  </p:clrMapOvr>
+</p:sld>
+</file>
+
+<file path=ppt/slides/slide6.xml><?xml version="1.0" encoding="utf-8"?>
+<p:sld xmlns:a="http://schemas.openxmlformats.org/drawingml/2006/main" xmlns:p="http://schemas.openxmlformats.org/presentationml/2006/main" xmlns:r="http://schemas.openxmlformats.org/officeDocument/2006/relationships">
+  <p:cSld>
+    <p:spTree>
+      <p:nvGrpSpPr>
+        <p:cNvPr id="1" name=""/>
+        <p:cNvGrpSpPr/>
+        <p:nvPr/>
+      </p:nvGrpSpPr>
+      <p:grpSpPr/>
+      <p:sp>
+        <p:nvSpPr>
+          <p:cNvPr id="4" name="Rectangle 3"/>
+          <p:cNvSpPr/>
+          <p:nvPr/>
+        </p:nvSpPr>
+        <p:spPr>
+          <a:xfrm>
+            <a:off x="-91440" y="6419088"/>
+            <a:ext cx="12435840" cy="548640"/>
+          </a:xfrm>
+          <a:prstGeom prst="rect">
+            <a:avLst/>
+          </a:prstGeom>
+          <a:solidFill>
+            <a:srgbClr val="3A7D34"/>
+          </a:solidFill>
+          <a:ln>
+            <a:noFill/>
+          </a:ln>
+          <a:effectLst/>
+        </p:spPr>
+        <p:style>
+          <a:lnRef idx="1">
+            <a:schemeClr val="accent1"/>
+          </a:lnRef>
+          <a:fillRef idx="3">
+            <a:schemeClr val="accent1"/>
+          </a:fillRef>
+          <a:effectRef idx="2">
+            <a:schemeClr val="accent1"/>
+          </a:effectRef>
+          <a:fontRef idx="minor">
+            <a:schemeClr val="lt1"/>
+          </a:fontRef>
+        </p:style>
+        <p:txBody>
+          <a:bodyPr rtlCol="0" anchor="ctr"/>
+          <a:lstStyle/>
+          <a:p>
+            <a:pPr algn="ctr"/>
+          </a:p>
+        </p:txBody>
+      </p:sp>
+      <p:sp>
+        <p:nvSpPr>
+          <p:cNvPr id="2" name="Title 1"/>
+          <p:cNvSpPr>
+            <a:spLocks noGrp="1"/>
+          </p:cNvSpPr>
+          <p:nvPr>
+            <p:ph type="title"/>
+          </p:nvPr>
+        </p:nvSpPr>
+        <p:spPr>
+          <a:xfrm>
+            <a:off x="640080" y="384048"/>
+            <a:ext cx="10972800" cy="868680"/>
+          </a:xfrm>
+        </p:spPr>
+        <p:txBody>
+          <a:bodyPr wrap="square" anchor="t"/>
+          <a:lstStyle/>
+          <a:p>
+            <a:pPr algn="l"/>
+            <a:r>
+              <a:rPr b="1" sz="2700">
+                <a:solidFill>
+                  <a:srgbClr val="3A7D34"/>
+                </a:solidFill>
+                <a:latin typeface="Trebuchet MS"/>
+              </a:rPr>
+              <a:t>What This Project Proves</a:t>
+            </a:r>
+          </a:p>
+        </p:txBody>
+      </p:sp>
+      <p:sp>
+        <p:nvSpPr>
+          <p:cNvPr id="3" name="Content Placeholder 2"/>
+          <p:cNvSpPr>
+            <a:spLocks noGrp="1"/>
+          </p:cNvSpPr>
+          <p:nvPr>
+            <p:ph idx="1"/>
+          </p:nvPr>
+        </p:nvSpPr>
+        <p:spPr>
+          <a:xfrm>
+            <a:off x="658368" y="1481328"/>
+            <a:ext cx="10972800" cy="4617720"/>
+          </a:xfrm>
+        </p:spPr>
+        <p:txBody>
+          <a:bodyPr wrap="square">
+            <a:normAutofit/>
+          </a:bodyPr>
+          <a:lstStyle/>
           <a:p>
             <a:pPr>
               <a:spcAft>
@@ -4569,6 +4509,102 @@
               </a:spcAft>
             </a:pPr>
             <a:r>
+              <a:rPr sz="1700" b="1">
+                <a:solidFill>
+                  <a:srgbClr val="3A7D34"/>
+                </a:solidFill>
+                <a:latin typeface="Verdana"/>
+              </a:rPr>
+              <a:t>Edge-first design pays off</a:t>
+            </a:r>
+          </a:p>
+          <a:p>
+            <a:pPr lvl="1">
+              <a:spcAft>
+                <a:spcPts val="900"/>
+              </a:spcAft>
+            </a:pPr>
+            <a:r>
+              <a:rPr sz="1500" b="0">
+                <a:solidFill>
+                  <a:srgbClr val="232A26"/>
+                </a:solidFill>
+                <a:latin typeface="Verdana"/>
+              </a:rPr>
+              <a:t>Aggregating and alerting at the fog node keeps raw readings local; alerts fire seconds after a threshold breaks.</a:t>
+            </a:r>
+          </a:p>
+          <a:p>
+            <a:pPr>
+              <a:spcAft>
+                <a:spcPts val="900"/>
+              </a:spcAft>
+            </a:pPr>
+            <a:r>
+              <a:rPr sz="1700" b="1">
+                <a:solidFill>
+                  <a:srgbClr val="3A7D34"/>
+                </a:solidFill>
+                <a:latin typeface="Verdana"/>
+              </a:rPr>
+              <a:t>Serverless scales without provisioning</a:t>
+            </a:r>
+          </a:p>
+          <a:p>
+            <a:pPr lvl="1">
+              <a:spcAft>
+                <a:spcPts val="900"/>
+              </a:spcAft>
+            </a:pPr>
+            <a:r>
+              <a:rPr sz="1500" b="0">
+                <a:solidFill>
+                  <a:srgbClr val="232A26"/>
+                </a:solidFill>
+                <a:latin typeface="Verdana"/>
+              </a:rPr>
+              <a:t>SQS, Lambda, and DynamoDB rode out a 67-message-per-second burst with nothing pre-sized or pre-warmed.</a:t>
+            </a:r>
+          </a:p>
+          <a:p>
+            <a:pPr>
+              <a:spcAft>
+                <a:spcPts val="900"/>
+              </a:spcAft>
+            </a:pPr>
+            <a:r>
+              <a:rPr sz="1700" b="1">
+                <a:solidFill>
+                  <a:srgbClr val="3A7D34"/>
+                </a:solidFill>
+                <a:latin typeface="Verdana"/>
+              </a:rPr>
+              <a:t>An emulator is not the cloud</a:t>
+            </a:r>
+          </a:p>
+          <a:p>
+            <a:pPr lvl="1">
+              <a:spcAft>
+                <a:spcPts val="900"/>
+              </a:spcAft>
+            </a:pPr>
+            <a:r>
+              <a:rPr sz="1500" b="0">
+                <a:solidFill>
+                  <a:srgbClr val="232A26"/>
+                </a:solidFill>
+                <a:latin typeface="Verdana"/>
+              </a:rPr>
+              <a:t>Two defects passed every local test and only surfaced against the real AWS deployment.</a:t>
+            </a:r>
+          </a:p>
+          <a:p>
+            <a:pPr>
+              <a:spcAft>
+                <a:spcPts val="900"/>
+              </a:spcAft>
+            </a:pPr>
+            <a:r>
               <a:rPr sz="1700" b="0">
                 <a:solidFill>
                   <a:srgbClr val="232A26"/>
@@ -4582,36 +4618,45 @@
       </p:sp>
       <p:sp>
         <p:nvSpPr>
-          <p:cNvPr id="5" name="TextBox 4"/>
-          <p:cNvSpPr txBox="1"/>
+          <p:cNvPr id="5" name="Rectangle 4"/>
+          <p:cNvSpPr/>
           <p:nvPr/>
         </p:nvSpPr>
         <p:spPr>
           <a:xfrm>
-            <a:off x="502920" y="6126480"/>
-            <a:ext cx="1097280" cy="457200"/>
+            <a:off x="658368" y="1261872"/>
+            <a:ext cx="3108960" cy="36576"/>
           </a:xfrm>
           <a:prstGeom prst="rect">
             <a:avLst/>
           </a:prstGeom>
-          <a:noFill/>
+          <a:solidFill>
+            <a:srgbClr val="3A7D34"/>
+          </a:solidFill>
+          <a:ln>
+            <a:noFill/>
+          </a:ln>
+          <a:effectLst/>
         </p:spPr>
-        <p:txBody>
-          <a:bodyPr wrap="square" anchor="t">
-            <a:spAutoFit/>
-          </a:bodyPr>
-          <a:lstStyle/>
-          <a:p>
-            <a:pPr algn="l"/>
-            <a:r>
-              <a:rPr sz="1400" b="1" i="0">
-                <a:solidFill>
-                  <a:srgbClr val="FFFFFF"/>
-                </a:solidFill>
-                <a:latin typeface="Trebuchet MS"/>
-              </a:rPr>
-              <a:t>05</a:t>
-            </a:r>
+        <p:style>
+          <a:lnRef idx="1">
+            <a:schemeClr val="accent1"/>
+          </a:lnRef>
+          <a:fillRef idx="3">
+            <a:schemeClr val="accent1"/>
+          </a:fillRef>
+          <a:effectRef idx="2">
+            <a:schemeClr val="accent1"/>
+          </a:effectRef>
+          <a:fontRef idx="minor">
+            <a:schemeClr val="lt1"/>
+          </a:fontRef>
+        </p:style>
+        <p:txBody>
+          <a:bodyPr rtlCol="0" anchor="ctr"/>
+          <a:lstStyle/>
+          <a:p>
+            <a:pPr algn="ctr"/>
           </a:p>
         </p:txBody>
       </p:sp>

</xml_diff>